<commit_message>
Redesign Xiaohongshu editorial carousel
</commit_message>
<xml_diff>
--- a/xiaohongshu/AI科研作图-小红书9页.pptx
+++ b/xiaohongshu/AI科研作图-小红书9页.pptx
@@ -1979,7 +1979,7 @@
                 <a:ea typeface="Microsoft YaHei" pitchFamily="34" charset="-122"/>
                 <a:cs typeface="Microsoft YaHei" pitchFamily="34" charset="-120"/>
               </a:rPr>
-              <a:t>博士生整理的 74 页科研作图分享</a:t>
+              <a:t>博士生整理的 73 页科研作图分享</a:t>
             </a:r>
             <a:endParaRPr lang="en-US" sz="2200" dirty="0"/>
           </a:p>
@@ -10480,7 +10480,7 @@
                 <a:ea typeface="Microsoft YaHei" pitchFamily="34" charset="-122"/>
                 <a:cs typeface="Microsoft YaHei" pitchFamily="34" charset="-120"/>
               </a:rPr>
-              <a:t>74 页</a:t>
+              <a:t>73 页</a:t>
             </a:r>
             <a:endParaRPr lang="en-US" sz="950" dirty="0"/>
           </a:p>
@@ -11020,7 +11020,7 @@
         <p:spPr>
           <a:xfrm>
             <a:off x="566928" y="8229600"/>
-            <a:ext cx="2926080" cy="237744"/>
+            <a:ext cx="5669280" cy="237744"/>
           </a:xfrm>
           <a:prstGeom prst="rect">
             <a:avLst/>
@@ -11044,7 +11044,7 @@
                 <a:ea typeface="Microsoft YaHei" pitchFamily="34" charset="-122"/>
                 <a:cs typeface="Microsoft YaHei" pitchFamily="34" charset="-120"/>
               </a:rPr>
-              <a:t>GitHub：发布时补充</a:t>
+              <a:t>GitHub：github.com/nanfengy/ai-research-visualization</a:t>
             </a:r>
             <a:endParaRPr lang="en-US" sz="950" dirty="0"/>
           </a:p>

</xml_diff>